<commit_message>
Docs: position Nexus as Agentic CX platform
Update README + overview docs with customer/frontline/ops agent framing and outcomes, and refresh both PPT decks to match.

Co-authored-by: Cursor <cursoragent@cursor.com>
</commit_message>
<xml_diff>
--- a/Nexus_Overview.pptx
+++ b/Nexus_Overview.pptx
@@ -3255,7 +3255,7 @@
           <a:lstStyle/>
           <a:p>
             <a:pPr algn="l">
-              <a:defRPr sz="2200" b="0">
+              <a:defRPr sz="2000" b="0">
                 <a:solidFill>
                   <a:srgbClr val="90AACC"/>
                 </a:solidFill>
@@ -3263,7 +3263,7 @@
               </a:defRPr>
             </a:pPr>
             <a:r>
-              <a:t>Open-Source Omnichannel AI Agent Platform</a:t>
+              <a:t>Purpose-built AI agents. One CX platform. (Open-source)</a:t>
             </a:r>
           </a:p>
         </p:txBody>
@@ -6274,12 +6274,17 @@
               </a:defRPr>
             </a:pPr>
             <a:r>
-              <a:t>Nexus is an open-source omnichannel AI agent platform for customer support. It solves the problem of fragmented support tools by providing a single AI-powered orchestrator that handles conversations across chat, copilot, and voice from one runtime.</a:t>
+              <a:t>Nexus is an open-source Agentic CX platform for customer experience teams. It solves the problem of fragmented support tools by providing a single AI-powered orchestrator that runs customer and agent workflows across chat, copilot, and voice.</a:t>
             </a:r>
             <a:br/>
             <a:br/>
             <a:r>
-              <a:t>One knowledge base, one feedback loop, one console — no more switching between siloed systems. Nexus ships with a built-in mock LLM so the entire platform runs without any API keys, making it fully functional for local development and testing out of the box.</a:t>
+              <a:t>Purpose-built agents can resolve customer inquiries end-to-end, guide frontline teams in real time, and support operations with evaluation and insights — all grounded with a shared knowledge layer (RAG).</a:t>
+            </a:r>
+            <a:br/>
+            <a:br/>
+            <a:r>
+              <a:t>Nexus ships with a built-in mock LLM so the platform runs without any API keys, making it fully functional for local development and testing out of the box.</a:t>
             </a:r>
           </a:p>
         </p:txBody>

</xml_diff>